<commit_message>
W04 D2 decks: the shop read by its added hours, five page rules, and the case said with what it rests on
Chapter 1 divides the shop's rise by the two hours it bought. S69 carries the five page rules that S84,
the brief and the notebooks check. The case's saving names the enrolled drivers, the six weeks, its
assumption and the per-trip rate; S46 teaches where the idle money sat; S71 and S73 fix the check's
period and the two-app direction; the transcripts' slides, D89 and S90 follow the rewritten answers.

Co-Authored-By: Claude Opus 5.5 <noreply@anthropic.com>
Claude-Session: https://claude.ai/code/session_0198Piji4xg3t6od7p7Ewqmt
</commit_message>
<xml_diff>
--- a/content/W04/D2/slides/C2_W04_D02_half2_STUDENT.pptx
+++ b/content/W04/D2/slides/C2_W04_D02_half2_STUDENT.pptx
@@ -545,12 +545,12 @@
           <a:lstStyle/>
           <a:p>
             <a:r>
-              <a:t>LIVE, 20 minutes, straight after lunch. Two turns of seven minutes, then six to rebuild: the</a:t>
-            </a:r>
-          </a:p>
-          <a:p>
-            <a:r>
-              <a:t>studio run sheet's two-turn fallback. The member who presented first in round one objects first</a:t>
+              <a:t>LIVE, 20 minutes, straight after lunch. Two turns of seven minutes, then six to rebuild, as the</a:t>
+            </a:r>
+          </a:p>
+          <a:p>
+            <a:r>
+              <a:t>trainer's studio run sheet sets round two. The member who presented first in round one objects first</a:t>
             </a:r>
           </a:p>
           <a:p>
@@ -1115,7 +1115,12 @@
           </a:p>
           <a:p>
             <a:r>
-              <a:t>three lines and checks your own page the same way. Transition: the rules.</a:t>
+              <a:t>three lines and runs the five rules of S69 on both versions: the draft passes none of them.</a:t>
+            </a:r>
+          </a:p>
+          <a:p>
+            <a:r>
+              <a:t>Transition: the rules.</a:t>
             </a:r>
           </a:p>
         </p:txBody>
@@ -1285,7 +1290,12 @@
           </a:p>
           <a:p>
             <a:r>
-              <a:t>explorable explanations (explorer scene T3, the guesstimate tree with a slider per factor).</a:t>
+              <a:t>explorable explanations (the week's explorer at content/W04/D1/demos/C2_W04_D01_week_explorer_STUDENT.html, scene T3,</a:t>
+            </a:r>
+          </a:p>
+          <a:p>
+            <a:r>
+              <a:t>the guesstimate tree with a slider per factor).</a:t>
             </a:r>
           </a:p>
           <a:p>
@@ -2745,17 +2755,22 @@
           <a:lstStyle/>
           <a:p>
             <a:r>
-              <a:t>LIVE, 2 minutes. The checklist handed back after the slot asks five things: the claim first, one</a:t>
-            </a:r>
-          </a:p>
-          <a:p>
-            <a:r>
-              <a:t>number with its denominator, the caveat in sight, the action with its cost and signer, no method</a:t>
-            </a:r>
-          </a:p>
-          <a:p>
-            <a:r>
-              <a:t>words. Nothing is graded. Chapter 7's page for Ramesh is the worked example.</a:t>
+              <a:t>LIVE, 2 minutes. The checklist handed back after the slot is S69's five rules as five questions: the</a:t>
+            </a:r>
+          </a:p>
+          <a:p>
+            <a:r>
+              <a:t>claim first with what to do and why, one number with what it is divided by and its window, the</a:t>
+            </a:r>
+          </a:p>
+          <a:p>
+            <a:r>
+              <a:t>caveat before the action, the action with its cost and who signs, and no method word. Nothing is</a:t>
+            </a:r>
+          </a:p>
+          <a:p>
+            <a:r>
+              <a:t>graded. Chapter 7's page for Ramesh is the worked example.</a:t>
             </a:r>
           </a:p>
           <a:p>
@@ -2830,7 +2845,12 @@
           <a:lstStyle/>
           <a:p>
             <a:r>
-              <a:t>LIVE, 32 minutes of silent writing. Walk once early to answer scope questions and once near the</a:t>
+              <a:t>LIVE, 32 minutes of silent writing; with the 3 minutes of S83 and S84 the chapter is the 35 the</a:t>
+            </a:r>
+          </a:p>
+          <a:p>
+            <a:r>
+              <a:t>brief names. Walk once early to answer scope questions and once near the</a:t>
             </a:r>
           </a:p>
           <a:p>
@@ -3080,17 +3100,22 @@
           </a:p>
           <a:p>
             <a:r>
-              <a:t>blur the claim. The full hire-grade answer, with the per-driver-week line checked (each driver</a:t>
-            </a:r>
-          </a:p>
-          <a:p>
-            <a:r>
-              <a:t>online four more hours a week at 17 percent less per hour; the 140 joiners pulled the read down), is</a:t>
-            </a:r>
-          </a:p>
-          <a:p>
-            <a:r>
-              <a:t>in extras/C2_W04_D02_interview_room_STUDENT.md, and notebook 10 recomputes every number it speaks.</a:t>
+              <a:t>blur the claim. The full hire-grade answer, with the per-driver-week line checked (the idle tail's</a:t>
+            </a:r>
+          </a:p>
+          <a:p>
+            <a:r>
+              <a:t>180 drivers doubled their online hours while each hour earned 17 percent less; the 140 joiners pulled</a:t>
+            </a:r>
+          </a:p>
+          <a:p>
+            <a:r>
+              <a:t>the read down), is in extras/C2_W04_D02_interview_room_STUDENT.md, and notebook 10 recomputes the</a:t>
+            </a:r>
+          </a:p>
+          <a:p>
+            <a:r>
+              <a:t>numbers it speaks.</a:t>
             </a:r>
           </a:p>
           <a:p>
@@ -3345,7 +3370,17 @@
           </a:p>
           <a:p>
             <a:r>
-              <a:t>both keep the visible number while the north star does the judging. The study: Ziegler and</a:t>
+              <a:t>both keep the visible number while the north star does the judging. Check the units: 32 of 100</a:t>
+            </a:r>
+          </a:p>
+          <a:p>
+            <a:r>
+              <a:t>suggestions accepted, and a fifth of those deleted, leaves about 26 of 100 suggestions shown; a</a:t>
+            </a:r>
+          </a:p>
+          <a:p>
+            <a:r>
+              <a:t>share of characters would not multiply into a share of suggestions. The study: Ziegler and</a:t>
             </a:r>
           </a:p>
           <a:p>
@@ -14595,8 +14630,8 @@
         </p:blipFill>
         <p:spPr>
           <a:xfrm>
-            <a:off x="530352" y="2112501"/>
-            <a:ext cx="4786326" cy="3132868"/>
+            <a:off x="530352" y="2356205"/>
+            <a:ext cx="4786326" cy="2645461"/>
           </a:xfrm>
           <a:prstGeom prst="rect">
             <a:avLst/>
@@ -14611,7 +14646,7 @@
         </p:nvSpPr>
         <p:spPr>
           <a:xfrm>
-            <a:off x="530352" y="5281946"/>
+            <a:off x="530352" y="5038242"/>
             <a:ext cx="4786326" cy="524256"/>
           </a:xfrm>
           <a:prstGeom prst="rect">
@@ -15525,7 +15560,7 @@
                 </a:solidFill>
                 <a:latin typeface="Georgia"/>
               </a:rPr>
-              <a:t>Four rules for a page read in two minutes</a:t>
+              <a:t>Five rules for a page read in two minutes</a:t>
             </a:r>
           </a:p>
         </p:txBody>
@@ -15843,13 +15878,82 @@
       </p:sp>
       <p:sp>
         <p:nvSpPr>
-          <p:cNvPr id="17" name="Rounded Rectangle 16"/>
+          <p:cNvPr id="17" name="TextBox 16"/>
+          <p:cNvSpPr txBox="1"/>
+          <p:nvPr/>
+        </p:nvSpPr>
+        <p:spPr>
+          <a:xfrm>
+            <a:off x="530352" y="3413760"/>
+            <a:ext cx="502920" cy="333756"/>
+          </a:xfrm>
+          <a:prstGeom prst="rect">
+            <a:avLst/>
+          </a:prstGeom>
+          <a:noFill/>
+        </p:spPr>
+        <p:txBody>
+          <a:bodyPr wrap="square" anchor="t" lIns="0" rIns="0" tIns="0" bIns="0">
+            <a:spAutoFit/>
+          </a:bodyPr>
+          <a:lstStyle/>
+          <a:p>
+            <a:pPr algn="l"/>
+            <a:r>
+              <a:rPr sz="1800" b="0" i="0">
+                <a:solidFill>
+                  <a:srgbClr val="5B3FD6"/>
+                </a:solidFill>
+                <a:latin typeface="Georgia"/>
+              </a:rPr>
+              <a:t>05</a:t>
+            </a:r>
+          </a:p>
+        </p:txBody>
+      </p:sp>
+      <p:sp>
+        <p:nvSpPr>
+          <p:cNvPr id="18" name="TextBox 17"/>
+          <p:cNvSpPr txBox="1"/>
+          <p:nvPr/>
+        </p:nvSpPr>
+        <p:spPr>
+          <a:xfrm>
+            <a:off x="1097280" y="3450336"/>
+            <a:ext cx="10564063" cy="368808"/>
+          </a:xfrm>
+          <a:prstGeom prst="rect">
+            <a:avLst/>
+          </a:prstGeom>
+          <a:noFill/>
+        </p:spPr>
+        <p:txBody>
+          <a:bodyPr wrap="square" anchor="t" lIns="0" rIns="0" tIns="0" bIns="0">
+            <a:spAutoFit/>
+          </a:bodyPr>
+          <a:lstStyle/>
+          <a:p>
+            <a:r>
+              <a:rPr sz="1500" b="0" i="0">
+                <a:solidFill>
+                  <a:srgbClr val="1A1440"/>
+                </a:solidFill>
+                <a:latin typeface="Calibri"/>
+              </a:rPr>
+              <a:t>No method word stays on the page: write "divided by", never "denominator".</a:t>
+            </a:r>
+          </a:p>
+        </p:txBody>
+      </p:sp>
+      <p:sp>
+        <p:nvSpPr>
+          <p:cNvPr id="19" name="Rounded Rectangle 18"/>
           <p:cNvSpPr/>
           <p:nvPr/>
         </p:nvSpPr>
         <p:spPr>
           <a:xfrm>
-            <a:off x="530352" y="3560064"/>
+            <a:off x="530352" y="4002024"/>
             <a:ext cx="11130991" cy="862584"/>
           </a:xfrm>
           <a:prstGeom prst="roundRect">
@@ -15897,13 +16001,13 @@
       </p:sp>
       <p:sp>
         <p:nvSpPr>
-          <p:cNvPr id="18" name="Oval 17"/>
+          <p:cNvPr id="20" name="Oval 19"/>
           <p:cNvSpPr/>
           <p:nvPr/>
         </p:nvSpPr>
         <p:spPr>
           <a:xfrm>
-            <a:off x="758952" y="3762756"/>
+            <a:off x="758952" y="4204716"/>
             <a:ext cx="457200" cy="457200"/>
           </a:xfrm>
           <a:prstGeom prst="ellipse">
@@ -15941,7 +16045,7 @@
       </p:sp>
       <p:pic>
         <p:nvPicPr>
-          <p:cNvPr id="19" name="Picture 18" descr="mic_caee7398c80d.png"/>
+          <p:cNvPr id="21" name="Picture 20" descr="mic_caee7398c80d.png"/>
           <p:cNvPicPr>
             <a:picLocks noChangeAspect="1"/>
           </p:cNvPicPr>
@@ -15955,7 +16059,7 @@
         </p:blipFill>
         <p:spPr>
           <a:xfrm>
-            <a:off x="868680" y="3872484"/>
+            <a:off x="868680" y="4314444"/>
             <a:ext cx="237744" cy="237744"/>
           </a:xfrm>
           <a:prstGeom prst="rect">
@@ -15965,13 +16069,13 @@
       </p:pic>
       <p:sp>
         <p:nvSpPr>
-          <p:cNvPr id="20" name="TextBox 19"/>
-          <p:cNvSpPr txBox="1"/>
-          <p:nvPr/>
-        </p:nvSpPr>
-        <p:spPr>
-          <a:xfrm>
-            <a:off x="1399031" y="3706368"/>
+          <p:cNvPr id="22" name="TextBox 21"/>
+          <p:cNvSpPr txBox="1"/>
+          <p:nvPr/>
+        </p:nvSpPr>
+        <p:spPr>
+          <a:xfrm>
+            <a:off x="1399031" y="4148328"/>
             <a:ext cx="9987991" cy="160401"/>
           </a:xfrm>
           <a:prstGeom prst="rect">
@@ -16000,13 +16104,13 @@
       </p:sp>
       <p:sp>
         <p:nvSpPr>
-          <p:cNvPr id="21" name="TextBox 20"/>
-          <p:cNvSpPr txBox="1"/>
-          <p:nvPr/>
-        </p:nvSpPr>
-        <p:spPr>
-          <a:xfrm>
-            <a:off x="1399031" y="3925824"/>
+          <p:cNvPr id="23" name="TextBox 22"/>
+          <p:cNvSpPr txBox="1"/>
+          <p:nvPr/>
+        </p:nvSpPr>
+        <p:spPr>
+          <a:xfrm>
+            <a:off x="1399031" y="4367784"/>
             <a:ext cx="9987991" cy="423672"/>
           </a:xfrm>
           <a:prstGeom prst="rect">
@@ -16034,7 +16138,7 @@
       </p:sp>
       <p:pic>
         <p:nvPicPr>
-          <p:cNvPr id="22" name="mermaid diagram" descr="37d776c03f3287af.png"/>
+          <p:cNvPr id="24" name="mermaid diagram" descr="37d776c03f3287af.png"/>
           <p:cNvPicPr>
             <a:picLocks noChangeAspect="1"/>
           </p:cNvPicPr>
@@ -16048,8 +16152,8 @@
         </p:blipFill>
         <p:spPr>
           <a:xfrm>
-            <a:off x="2393927" y="4587240"/>
-            <a:ext cx="7403840" cy="1612392"/>
+            <a:off x="3408631" y="5029200"/>
+            <a:ext cx="5374432" cy="1170432"/>
           </a:xfrm>
           <a:prstGeom prst="rect">
             <a:avLst/>
@@ -16058,7 +16162,7 @@
       </p:pic>
       <p:sp>
         <p:nvSpPr>
-          <p:cNvPr id="23" name="Oval 22"/>
+          <p:cNvPr id="25" name="Oval 24"/>
           <p:cNvSpPr/>
           <p:nvPr/>
         </p:nvSpPr>
@@ -16102,7 +16206,7 @@
       </p:sp>
       <p:sp>
         <p:nvSpPr>
-          <p:cNvPr id="24" name="TextBox 23"/>
+          <p:cNvPr id="26" name="TextBox 25"/>
           <p:cNvSpPr txBox="1"/>
           <p:nvPr/>
         </p:nvSpPr>
@@ -16137,7 +16241,7 @@
       </p:sp>
       <p:sp>
         <p:nvSpPr>
-          <p:cNvPr id="25" name="Oval 24"/>
+          <p:cNvPr id="27" name="Oval 26"/>
           <p:cNvSpPr/>
           <p:nvPr/>
         </p:nvSpPr>
@@ -16181,7 +16285,7 @@
       </p:sp>
       <p:sp>
         <p:nvSpPr>
-          <p:cNvPr id="26" name="TextBox 25"/>
+          <p:cNvPr id="28" name="TextBox 27"/>
           <p:cNvSpPr txBox="1"/>
           <p:nvPr/>
         </p:nvSpPr>
@@ -16216,7 +16320,7 @@
       </p:sp>
       <p:sp>
         <p:nvSpPr>
-          <p:cNvPr id="27" name="Oval 26"/>
+          <p:cNvPr id="29" name="Oval 28"/>
           <p:cNvSpPr/>
           <p:nvPr/>
         </p:nvSpPr>
@@ -16260,7 +16364,7 @@
       </p:sp>
       <p:sp>
         <p:nvSpPr>
-          <p:cNvPr id="28" name="TextBox 27"/>
+          <p:cNvPr id="30" name="TextBox 29"/>
           <p:cNvSpPr txBox="1"/>
           <p:nvPr/>
         </p:nvSpPr>
@@ -16295,7 +16399,7 @@
       </p:sp>
       <p:sp>
         <p:nvSpPr>
-          <p:cNvPr id="29" name="Oval 28"/>
+          <p:cNvPr id="31" name="Oval 30"/>
           <p:cNvSpPr/>
           <p:nvPr/>
         </p:nvSpPr>
@@ -16339,7 +16443,7 @@
       </p:sp>
       <p:sp>
         <p:nvSpPr>
-          <p:cNvPr id="30" name="TextBox 29"/>
+          <p:cNvPr id="32" name="TextBox 31"/>
           <p:cNvSpPr txBox="1"/>
           <p:nvPr/>
         </p:nvSpPr>
@@ -16374,7 +16478,7 @@
       </p:sp>
       <p:sp>
         <p:nvSpPr>
-          <p:cNvPr id="31" name="Oval 30"/>
+          <p:cNvPr id="33" name="Oval 32"/>
           <p:cNvSpPr/>
           <p:nvPr/>
         </p:nvSpPr>
@@ -16418,7 +16522,7 @@
       </p:sp>
       <p:sp>
         <p:nvSpPr>
-          <p:cNvPr id="32" name="TextBox 31"/>
+          <p:cNvPr id="34" name="TextBox 33"/>
           <p:cNvSpPr txBox="1"/>
           <p:nvPr/>
         </p:nvSpPr>
@@ -16453,7 +16557,7 @@
       </p:sp>
       <p:sp>
         <p:nvSpPr>
-          <p:cNvPr id="33" name="TextBox 32"/>
+          <p:cNvPr id="35" name="TextBox 34"/>
           <p:cNvSpPr txBox="1"/>
           <p:nvPr/>
         </p:nvSpPr>
@@ -19849,7 +19953,7 @@
         <p:spPr>
           <a:xfrm>
             <a:off x="530352" y="1956816"/>
-            <a:ext cx="11130991" cy="1654048"/>
+            <a:ext cx="11130991" cy="1930400"/>
           </a:xfrm>
           <a:prstGeom prst="rect">
             <a:avLst/>
@@ -19922,7 +20026,7 @@
                 </a:solidFill>
                 <a:latin typeface="Calibri"/>
               </a:rPr>
-              <a:t>d) The online driver-hours behind each rider request in the case's own data</a:t>
+              <a:t>d) The online driver-hours behind each completed trip in the case's own data, pooled over both daily peak windows</a:t>
             </a:r>
           </a:p>
         </p:txBody>
@@ -20730,7 +20834,7 @@
                 </a:solidFill>
                 <a:latin typeface="Calibri"/>
               </a:rPr>
-              <a:t>a counts rider requests over six weeks in twelve zones: another unit, a longer period and a slice of the city. b counts sign-ups, a different definition from drivers online at one moment. d is not wrong: it checks one link in the chain, a ratio the case's own data holds, and when the direct check does not exist, that is the honest fallback the afternoon uses. Chapter 6's three tests decide each: same unit, same period, same definition.</a:t>
+              <a:t>a counts rider requests over six weeks in twelve zones: another unit, a longer period and a slice of the city. b counts sign-ups, a different definition from drivers online at one moment. d is not wrong: it checks one link in the chain, a ratio the case's own data holds over a wider period than one evening, and when the direct check does not exist, that is the honest fallback the afternoon uses. Chapter 6's three tests decide each: same unit, same period, same definition.</a:t>
             </a:r>
           </a:p>
         </p:txBody>
@@ -21415,8 +21519,8 @@
           <p:nvPr/>
         </p:nvGraphicFramePr>
         <p:xfrm>
-          <a:off x="530352" y="1872996"/>
-          <a:ext cx="11130990" cy="3072384"/>
+          <a:off x="530352" y="1682496"/>
+          <a:ext cx="11130990" cy="3314192"/>
         </p:xfrm>
         <a:graphic>
           <a:graphicData uri="http://schemas.openxmlformats.org/drawingml/2006/table">
@@ -21704,7 +21808,7 @@
                   </a:tcPr>
                 </a:tc>
               </a:tr>
-              <a:tr h="369824">
+              <a:tr h="611632">
                 <a:tc>
                   <a:txBody>
                     <a:bodyPr/>
@@ -21739,7 +21843,7 @@
                           </a:solidFill>
                           <a:latin typeface="Calibri"/>
                         </a:rPr>
-                        <a:t>A driver online on Uber may be busy on another app, so lean the idle share low</a:t>
+                        <a:t>A driver online on Uber may be on another app's trip, so more online drivers serve no Uber rider: lean the idle share high, which pushes the answer up</a:t>
                       </a:r>
                     </a:p>
                   </a:txBody>
@@ -21762,7 +21866,7 @@
         </p:nvSpPr>
         <p:spPr>
           <a:xfrm>
-            <a:off x="530352" y="5201412"/>
+            <a:off x="530352" y="5252720"/>
             <a:ext cx="11130991" cy="807720"/>
           </a:xfrm>
           <a:prstGeom prst="roundRect">
@@ -21810,7 +21914,7 @@
         </p:nvSpPr>
         <p:spPr>
           <a:xfrm>
-            <a:off x="676656" y="5329428"/>
+            <a:off x="676656" y="5380736"/>
             <a:ext cx="45720" cy="551688"/>
           </a:xfrm>
           <a:prstGeom prst="roundRect">
@@ -21856,7 +21960,7 @@
         </p:nvSpPr>
         <p:spPr>
           <a:xfrm>
-            <a:off x="877824" y="5320284"/>
+            <a:off x="877824" y="5371592"/>
             <a:ext cx="10564063" cy="624840"/>
           </a:xfrm>
           <a:prstGeom prst="rect">
@@ -27652,7 +27756,7 @@
         <p:spPr>
           <a:xfrm>
             <a:off x="530352" y="1956816"/>
-            <a:ext cx="11130991" cy="1074420"/>
+            <a:ext cx="11130991" cy="1341120"/>
           </a:xfrm>
           <a:prstGeom prst="roundRect">
             <a:avLst>
@@ -27700,7 +27804,7 @@
         <p:spPr>
           <a:xfrm>
             <a:off x="676656" y="2084832"/>
-            <a:ext cx="45720" cy="818388"/>
+            <a:ext cx="45720" cy="1085088"/>
           </a:xfrm>
           <a:prstGeom prst="roundRect">
             <a:avLst>
@@ -27746,7 +27850,7 @@
         <p:spPr>
           <a:xfrm>
             <a:off x="877824" y="2075688"/>
-            <a:ext cx="10564063" cy="891540"/>
+            <a:ext cx="10564063" cy="1158240"/>
           </a:xfrm>
           <a:prstGeom prst="rect">
             <a:avLst/>
@@ -27775,7 +27879,7 @@
                 </a:solidFill>
                 <a:latin typeface="Calibri"/>
               </a:rPr>
-              <a:t>Work in pairs for seven minutes, with all four steps on one sheet. Clarify volume or value (volume: the count of payments). Map active users x payments per user a day, and say how many of those go to shops and how many to people, so the payments a day are believable.</a:t>
+              <a:t>UPI is India's system for paying from a bank account by phone, by a code or a phone number. Work in pairs for seven minutes, with all four steps on one sheet. Clarify volume or value (volume: the count of payments). Map active users x payments per user a day, and say how many of those go to shops and how many to people, so the payments a day are believable.</a:t>
             </a:r>
           </a:p>
         </p:txBody>
@@ -27788,7 +27892,7 @@
         </p:nvSpPr>
         <p:spPr>
           <a:xfrm>
-            <a:off x="530352" y="3195828"/>
+            <a:off x="530352" y="3462528"/>
             <a:ext cx="11130991" cy="807720"/>
           </a:xfrm>
           <a:prstGeom prst="roundRect">
@@ -27836,7 +27940,7 @@
         </p:nvSpPr>
         <p:spPr>
           <a:xfrm>
-            <a:off x="676656" y="3323844"/>
+            <a:off x="676656" y="3590544"/>
             <a:ext cx="45720" cy="551688"/>
           </a:xfrm>
           <a:prstGeom prst="roundRect">
@@ -27882,7 +27986,7 @@
         </p:nvSpPr>
         <p:spPr>
           <a:xfrm>
-            <a:off x="877824" y="3314700"/>
+            <a:off x="877824" y="3581400"/>
             <a:ext cx="10564063" cy="624840"/>
           </a:xfrm>
           <a:prstGeom prst="rect">
@@ -34620,7 +34724,7 @@
                 </a:solidFill>
                 <a:latin typeface="Calibri"/>
               </a:rPr>
-              <a:t>One number and its denominator</a:t>
+              <a:t>One number, and what it is divided by</a:t>
             </a:r>
           </a:p>
         </p:txBody>
@@ -35746,7 +35850,7 @@
         <p:spPr>
           <a:xfrm>
             <a:off x="530352" y="1956816"/>
-            <a:ext cx="2645587" cy="2195576"/>
+            <a:ext cx="2645587" cy="2385568"/>
           </a:xfrm>
           <a:prstGeom prst="roundRect">
             <a:avLst>
@@ -35973,7 +36077,7 @@
         <p:spPr>
           <a:xfrm>
             <a:off x="3358819" y="1956816"/>
-            <a:ext cx="2645587" cy="2195576"/>
+            <a:ext cx="2645587" cy="2385568"/>
           </a:xfrm>
           <a:prstGeom prst="roundRect">
             <a:avLst>
@@ -36151,7 +36255,7 @@
                 </a:solidFill>
                 <a:latin typeface="Calibri"/>
               </a:rPr>
-              <a:t>One number and its denominator</a:t>
+              <a:t>One number, and what it is divided by</a:t>
             </a:r>
           </a:p>
         </p:txBody>
@@ -36165,7 +36269,7 @@
         <p:spPr>
           <a:xfrm>
             <a:off x="3559987" y="3534664"/>
-            <a:ext cx="2243251" cy="399796"/>
+            <a:ext cx="2243251" cy="581406"/>
           </a:xfrm>
           <a:prstGeom prst="rect">
             <a:avLst/>
@@ -36186,7 +36290,7 @@
                 </a:solidFill>
                 <a:latin typeface="Calibri"/>
               </a:rPr>
-              <a:t>The rupees per peak online hour, before and after</a:t>
+              <a:t>The rupees per peak online hour, before and after, with the window</a:t>
             </a:r>
           </a:p>
         </p:txBody>
@@ -36200,7 +36304,7 @@
         <p:spPr>
           <a:xfrm>
             <a:off x="6187287" y="1956816"/>
-            <a:ext cx="2645587" cy="2195576"/>
+            <a:ext cx="2645587" cy="2385568"/>
           </a:xfrm>
           <a:prstGeom prst="roundRect">
             <a:avLst>
@@ -36413,7 +36517,7 @@
                 </a:solidFill>
                 <a:latin typeface="Calibri"/>
               </a:rPr>
-              <a:t>In the body of the page, where the reader meets it before the action</a:t>
+              <a:t>Before the action, so the reader meets the doubt before the cost</a:t>
             </a:r>
           </a:p>
         </p:txBody>
@@ -36427,7 +36531,7 @@
         <p:spPr>
           <a:xfrm>
             <a:off x="9015755" y="1956816"/>
-            <a:ext cx="2645587" cy="2195576"/>
+            <a:ext cx="2645587" cy="2385568"/>
           </a:xfrm>
           <a:prstGeom prst="roundRect">
             <a:avLst>
@@ -36653,8 +36757,8 @@
         </p:nvSpPr>
         <p:spPr>
           <a:xfrm>
-            <a:off x="530352" y="4335272"/>
-            <a:ext cx="11130991" cy="1048512"/>
+            <a:off x="530352" y="4525264"/>
+            <a:ext cx="11130991" cy="1324864"/>
           </a:xfrm>
           <a:prstGeom prst="rect">
             <a:avLst/>
@@ -36688,7 +36792,7 @@
                 </a:solidFill>
                 <a:latin typeface="Calibri"/>
               </a:rPr>
-              <a:t> is the city head, with the three roles reading over a shoulder: finance reads rupees, driver operations reads drivers, marketing reads sign-ups. Words a non-technical reader would not know (denominator, index, guardrail) stay off the page, or are said in plain words.</a:t>
+              <a:t> is the city head, with the three roles reading over a shoulder: finance reads rupees, driver operations reads drivers, marketing reads sign-ups. Method words a non-technical reader would not know (denominator, index, guardrail, north star) stay off the page; say what each means instead. These are S69's five rules, unchanged.</a:t>
             </a:r>
           </a:p>
         </p:txBody>
@@ -40483,8 +40587,8 @@
           <p:nvPr/>
         </p:nvGraphicFramePr>
         <p:xfrm>
-          <a:off x="530352" y="1938782"/>
-          <a:ext cx="11130990" cy="2674112"/>
+          <a:off x="530352" y="1956816"/>
+          <a:ext cx="11130990" cy="2328672"/>
         </p:xfrm>
         <a:graphic>
           <a:graphicData uri="http://schemas.openxmlformats.org/drawingml/2006/table">
@@ -40496,14 +40600,14 @@
                 <a:gridCol w="5565495"/>
                 <a:gridCol w="5565495"/>
               </a:tblGrid>
-              <a:tr h="369824">
+              <a:tr h="335280">
                 <a:tc>
                   <a:txBody>
                     <a:bodyPr/>
                     <a:lstStyle/>
                     <a:p>
                       <a:r>
-                        <a:rPr sz="1450" b="1" i="0">
+                        <a:rPr sz="1250" b="1" i="0">
                           <a:solidFill>
                             <a:srgbClr val="FFFFFF"/>
                           </a:solidFill>
@@ -40525,7 +40629,7 @@
                     <a:lstStyle/>
                     <a:p>
                       <a:r>
-                        <a:rPr sz="1450" b="1" i="0">
+                        <a:rPr sz="1250" b="1" i="0">
                           <a:solidFill>
                             <a:srgbClr val="FFFFFF"/>
                           </a:solidFill>
@@ -40542,14 +40646,14 @@
                   </a:tcPr>
                 </a:tc>
               </a:tr>
-              <a:tr h="2304288">
+              <a:tr h="1993392">
                 <a:tc>
                   <a:txBody>
                     <a:bodyPr/>
                     <a:lstStyle/>
                     <a:p>
                       <a:r>
-                        <a:rPr sz="1400" b="0" i="0">
+                        <a:rPr sz="1200" b="0" i="0">
                           <a:solidFill>
                             <a:srgbClr val="1A1440"/>
                           </a:solidFill>
@@ -40571,13 +40675,13 @@
                     <a:lstStyle/>
                     <a:p>
                       <a:r>
-                        <a:rPr sz="1400" b="0" i="0">
+                        <a:rPr sz="1200" b="0" i="0">
                           <a:solidFill>
                             <a:srgbClr val="1A1440"/>
                           </a:solidFill>
                           <a:latin typeface="Calibri"/>
                         </a:rPr>
-                        <a:t>"You are deciding whether to keep, end or change the guarantee. It is paying for online hours that carry no trips: an hour online brought in Rs 314 of fares and now brings in Rs 260 at the same fare, while the median wait barely moved, 4.8 to 4.6 minutes. Part of the fall may be the monsoon. Test paying per completed trip with an acceptance floor on half the drivers, picked at random, for six weeks; city-wide it saves Rs 58 lakh to Rs 92.7 lakh. You sign the test."</a:t>
+                        <a:t>"You are deciding whether to keep, end or change the guarantee. It is paying for online hours that carry no trips: an hour online brought in Rs 314 of fares and now brings in Rs 260 at the same fare, while the median wait barely moved, 4.8 to 4.6 minutes. Part of the fall may be the monsoon. Test paying per completed trip with an acceptance floor on half the drivers, picked at random, for six weeks, at a per-trip rate fixed first; across the enrolled drivers it saves Rs 58 lakh to Rs 92.7 lakh over six weeks if a half to a fifth of the idle top-up is still paid. You sign the test."</a:t>
                       </a:r>
                     </a:p>
                   </a:txBody>
@@ -40600,8 +40704,8 @@
         </p:nvSpPr>
         <p:spPr>
           <a:xfrm>
-            <a:off x="530352" y="4868926"/>
-            <a:ext cx="11130991" cy="1074420"/>
+            <a:off x="530352" y="4541520"/>
+            <a:ext cx="11130991" cy="736600"/>
           </a:xfrm>
           <a:prstGeom prst="roundRect">
             <a:avLst>
@@ -40648,8 +40752,8 @@
         </p:nvSpPr>
         <p:spPr>
           <a:xfrm>
-            <a:off x="676656" y="4996942"/>
-            <a:ext cx="45720" cy="818388"/>
+            <a:off x="676656" y="4669536"/>
+            <a:ext cx="45720" cy="480568"/>
           </a:xfrm>
           <a:prstGeom prst="roundRect">
             <a:avLst>
@@ -40694,8 +40798,8 @@
         </p:nvSpPr>
         <p:spPr>
           <a:xfrm>
-            <a:off x="877824" y="4987798"/>
-            <a:ext cx="10564063" cy="891540"/>
+            <a:off x="877824" y="4660392"/>
+            <a:ext cx="10564063" cy="553720"/>
           </a:xfrm>
           <a:prstGeom prst="rect">
             <a:avLst/>
@@ -40709,7 +40813,7 @@
           <a:lstStyle/>
           <a:p>
             <a:r>
-              <a:rPr sz="1500" b="1">
+              <a:rPr sz="1300" b="1">
                 <a:solidFill>
                   <a:srgbClr val="5B3FD6"/>
                 </a:solidFill>
@@ -40718,7 +40822,7 @@
               <a:t>The follow-ups: </a:t>
             </a:r>
             <a:r>
-              <a:rPr sz="1500" b="0" i="0">
+              <a:rPr sz="1300" b="0" i="0">
                 <a:solidFill>
                   <a:srgbClr val="1A1440"/>
                 </a:solidFill>
@@ -41465,7 +41569,7 @@
         </p:nvGraphicFramePr>
         <p:xfrm>
           <a:off x="530352" y="1956816"/>
-          <a:ext cx="11130990" cy="2674112"/>
+          <a:ext cx="11130990" cy="2535936"/>
         </p:xfrm>
         <a:graphic>
           <a:graphicData uri="http://schemas.openxmlformats.org/drawingml/2006/table">
@@ -41477,14 +41581,14 @@
                 <a:gridCol w="5565495"/>
                 <a:gridCol w="5565495"/>
               </a:tblGrid>
-              <a:tr h="369824">
+              <a:tr h="335280">
                 <a:tc>
                   <a:txBody>
                     <a:bodyPr/>
                     <a:lstStyle/>
                     <a:p>
                       <a:r>
-                        <a:rPr sz="1450" b="1" i="0">
+                        <a:rPr sz="1250" b="1" i="0">
                           <a:solidFill>
                             <a:srgbClr val="FFFFFF"/>
                           </a:solidFill>
@@ -41506,7 +41610,7 @@
                     <a:lstStyle/>
                     <a:p>
                       <a:r>
-                        <a:rPr sz="1450" b="1" i="0">
+                        <a:rPr sz="1250" b="1" i="0">
                           <a:solidFill>
                             <a:srgbClr val="FFFFFF"/>
                           </a:solidFill>
@@ -41523,14 +41627,14 @@
                   </a:tcPr>
                 </a:tc>
               </a:tr>
-              <a:tr h="2304288">
+              <a:tr h="2200656">
                 <a:tc>
                   <a:txBody>
                     <a:bodyPr/>
                     <a:lstStyle/>
                     <a:p>
                       <a:r>
-                        <a:rPr sz="1400" b="0" i="0">
+                        <a:rPr sz="1200" b="0" i="0">
                           <a:solidFill>
                             <a:srgbClr val="1A1440"/>
                           </a:solidFill>
@@ -41552,13 +41656,13 @@
                     <a:lstStyle/>
                     <a:p>
                       <a:r>
-                        <a:rPr sz="1400" b="0" i="0">
+                        <a:rPr sz="1200" b="0" i="0">
                           <a:solidFill>
                             <a:srgbClr val="1A1440"/>
                           </a:solidFill>
                           <a:latin typeface="Calibri"/>
                         </a:rPr>
-                        <a:t>"One moment of the three-hour weekday evening peak, one product, the city's median wait under five minutes. Drivers online is trips an hour divided by the trips one online driver completes in an hour, times a buffer: 8,330 / 1.68 x 1.15, about 5,700; trips per person moves it most, 2,900 to 8,600. Like for like, the case's 0.53 driver-hours per trip against my 0.60 says I run an eighth high, so 5,000 to 5,700, and each thousand idle drivers costs up to Rs 9 lakh an evening at the floor."</a:t>
+                        <a:t>"One moment of the three-hour weekday evening peak, one product, the city's median wait under five minutes, the outer zones sized on their own. Drivers online is trips an hour divided by the trips one online driver completes in an hour, times a buffer: 8,330 / 1.68 x 1.15, about 5,700, more if many drivers run two apps; trips per person moves it most, 2,900 to 8,600. Like for like, the case's 0.53 driver-hours per trip, pooled over both daily peaks, against my 0.60 says I run an eighth high: about 5,000 to 5,700 where the routes agree, inside the wider range, and each thousand idle drivers costs up to Rs 9 lakh an evening at the floor."</a:t>
                       </a:r>
                     </a:p>
                   </a:txBody>
@@ -41581,8 +41685,8 @@
         </p:nvSpPr>
         <p:spPr>
           <a:xfrm>
-            <a:off x="530352" y="4886960"/>
-            <a:ext cx="11130991" cy="807720"/>
+            <a:off x="530352" y="4748784"/>
+            <a:ext cx="11130991" cy="736600"/>
           </a:xfrm>
           <a:prstGeom prst="roundRect">
             <a:avLst>
@@ -41629,8 +41733,8 @@
         </p:nvSpPr>
         <p:spPr>
           <a:xfrm>
-            <a:off x="676656" y="5014976"/>
-            <a:ext cx="45720" cy="551688"/>
+            <a:off x="676656" y="4876800"/>
+            <a:ext cx="45720" cy="480568"/>
           </a:xfrm>
           <a:prstGeom prst="roundRect">
             <a:avLst>
@@ -41675,8 +41779,8 @@
         </p:nvSpPr>
         <p:spPr>
           <a:xfrm>
-            <a:off x="877824" y="5005832"/>
-            <a:ext cx="10564063" cy="624840"/>
+            <a:off x="877824" y="4867656"/>
+            <a:ext cx="10564063" cy="553720"/>
           </a:xfrm>
           <a:prstGeom prst="rect">
             <a:avLst/>
@@ -41690,7 +41794,7 @@
           <a:lstStyle/>
           <a:p>
             <a:r>
-              <a:rPr sz="1500" b="1">
+              <a:rPr sz="1300" b="1">
                 <a:solidFill>
                   <a:srgbClr val="5B3FD6"/>
                 </a:solidFill>
@@ -41699,7 +41803,7 @@
               <a:t>The follow-ups: </a:t>
             </a:r>
             <a:r>
-              <a:rPr sz="1500" b="0" i="0">
+              <a:rPr sz="1300" b="0" i="0">
                 <a:solidFill>
                   <a:srgbClr val="1A1440"/>
                 </a:solidFill>
@@ -43493,7 +43597,7 @@
         <p:spPr>
           <a:xfrm>
             <a:off x="530352" y="1956816"/>
-            <a:ext cx="11130991" cy="1607820"/>
+            <a:ext cx="11130991" cy="2141220"/>
           </a:xfrm>
           <a:prstGeom prst="roundRect">
             <a:avLst>
@@ -43541,7 +43645,7 @@
         <p:spPr>
           <a:xfrm>
             <a:off x="676656" y="2084832"/>
-            <a:ext cx="45720" cy="1351788"/>
+            <a:ext cx="45720" cy="1885187"/>
           </a:xfrm>
           <a:prstGeom prst="roundRect">
             <a:avLst>
@@ -43587,7 +43691,7 @@
         <p:spPr>
           <a:xfrm>
             <a:off x="877824" y="2075688"/>
-            <a:ext cx="10564063" cy="1424940"/>
+            <a:ext cx="10564063" cy="1958340"/>
           </a:xfrm>
           <a:prstGeom prst="rect">
             <a:avLst/>
@@ -43616,7 +43720,7 @@
                 </a:solidFill>
                 <a:latin typeface="Calibri"/>
               </a:rPr>
-              <a:t>A coding assistant's sales deck quotes "acceptance rate 32 percent", the share of suggestions developers accept, even ones deleted soon after. The analyst proposes a new </a:t>
+              <a:t>A coding assistant's sales deck quotes "acceptance rate 32 percent", the share of suggestions developers accept, even ones deleted soon after; if a fifth of accepted suggestions are deleted within a week, about 26 of every 100 shown survive. The analyst proposes a new </a:t>
             </a:r>
             <a:r>
               <a:rPr sz="1500" b="1" i="0">
@@ -43634,7 +43738,7 @@
                 </a:solidFill>
                 <a:latin typeface="Calibri"/>
               </a:rPr>
-              <a:t>, the one number the team is judged on: characters of suggested code still in the file seven days after acceptance, per developer who saw a suggestion that week, with two </a:t>
+              <a:t>, the one number the team is judged on: characters of suggested code still in the file seven days after acceptance, per paid seat a week (a seat is one developer's paid licence), so a developer who switches the tool off still counts. Two </a:t>
             </a:r>
             <a:r>
               <a:rPr sz="1500" b="1" i="0">
@@ -43652,7 +43756,7 @@
                 </a:solidFill>
                 <a:latin typeface="Calibri"/>
               </a:rPr>
-              <a:t> that catch padding (retained characters per accepted character; edits per accepted suggestion).</a:t>
+              <a:t>, numbers that must not get worse, catch padding: characters per accepted suggestion, and a monthly sample of surviving suggestions read by engineers.</a:t>
             </a:r>
           </a:p>
         </p:txBody>
@@ -43665,7 +43769,7 @@
         </p:nvSpPr>
         <p:spPr>
           <a:xfrm>
-            <a:off x="530352" y="3729228"/>
+            <a:off x="530352" y="4262627"/>
             <a:ext cx="11130991" cy="1341120"/>
           </a:xfrm>
           <a:prstGeom prst="roundRect">
@@ -43713,7 +43817,7 @@
         </p:nvSpPr>
         <p:spPr>
           <a:xfrm>
-            <a:off x="676656" y="3857244"/>
+            <a:off x="676656" y="4390643"/>
             <a:ext cx="45720" cy="1085088"/>
           </a:xfrm>
           <a:prstGeom prst="roundRect">
@@ -43759,7 +43863,7 @@
         </p:nvSpPr>
         <p:spPr>
           <a:xfrm>
-            <a:off x="877824" y="3848100"/>
+            <a:off x="877824" y="4381499"/>
             <a:ext cx="10564063" cy="1158240"/>
           </a:xfrm>
           <a:prstGeom prst="rect">
@@ -43825,7 +43929,7 @@
                 </a:solidFill>
                 <a:latin typeface="Calibri"/>
               </a:rPr>
-              <a:t>, a number that moves first, and switches the team's judgement to surviving code once a holdout of users shows it tracks seat renewals.</a:t>
+              <a:t>, a number that moves first, and judges the team on surviving code once last year's renewals show it separates the accounts that renewed from those that cut seats better than acceptance does.</a:t>
             </a:r>
           </a:p>
         </p:txBody>
@@ -44511,7 +44615,7 @@
         </p:nvGraphicFramePr>
         <p:xfrm>
           <a:off x="530352" y="1956816"/>
-          <a:ext cx="11130989" cy="2682240"/>
+          <a:ext cx="11130989" cy="3511296"/>
         </p:xfrm>
         <a:graphic>
           <a:graphicData uri="http://schemas.openxmlformats.org/drawingml/2006/table">
@@ -44520,10 +44624,10 @@
                 <a:tableStyleId>{2D5ABB26-0587-4C30-8999-92F81FD0307C}</a:tableStyleId>
               </a:tblPr>
               <a:tblGrid>
-                <a:gridCol w="4890706"/>
-                <a:gridCol w="1369720"/>
-                <a:gridCol w="1833007"/>
-                <a:gridCol w="3037556"/>
+                <a:gridCol w="3720477"/>
+                <a:gridCol w="1041978"/>
+                <a:gridCol w="1394413"/>
+                <a:gridCol w="4974121"/>
               </a:tblGrid>
               <a:tr h="335280">
                 <a:tc>
@@ -44615,7 +44719,7 @@
                   </a:tcPr>
                 </a:tc>
               </a:tr>
-              <a:tr h="335280">
+              <a:tr h="542544">
                 <a:tc>
                   <a:txBody>
                     <a:bodyPr/>
@@ -44694,7 +44798,7 @@
                           </a:solidFill>
                           <a:latin typeface="Calibri"/>
                         </a:rPr>
-                        <a:t>unit, window and target pinned</a:t>
+                        <a:t>what is decided or counted, the window, and the target or the audience pinned</a:t>
                       </a:r>
                     </a:p>
                   </a:txBody>
@@ -44705,7 +44809,7 @@
                   </a:tcPr>
                 </a:tc>
               </a:tr>
-              <a:tr h="335280">
+              <a:tr h="542544">
                 <a:tc>
                   <a:txBody>
                     <a:bodyPr/>
@@ -44885,7 +44989,7 @@
                   </a:tcPr>
                 </a:tc>
               </a:tr>
-              <a:tr h="335280">
+              <a:tr h="542544">
                 <a:tc>
                   <a:txBody>
                     <a:bodyPr/>
@@ -45155,7 +45259,7 @@
                   </a:tcPr>
                 </a:tc>
               </a:tr>
-              <a:tr h="335280">
+              <a:tr h="542544">
                 <a:tc>
                   <a:txBody>
                     <a:bodyPr/>
@@ -48253,8 +48357,8 @@
         </p:nvSpPr>
         <p:spPr>
           <a:xfrm>
-            <a:off x="530352" y="1908556"/>
-            <a:ext cx="45720" cy="1605279"/>
+            <a:off x="530352" y="1682496"/>
+            <a:ext cx="45720" cy="1889759"/>
           </a:xfrm>
           <a:prstGeom prst="roundRect">
             <a:avLst>
@@ -48299,8 +48403,8 @@
         </p:nvSpPr>
         <p:spPr>
           <a:xfrm>
-            <a:off x="786384" y="1908556"/>
-            <a:ext cx="10820095" cy="1605279"/>
+            <a:off x="786384" y="1682496"/>
+            <a:ext cx="10820095" cy="1889759"/>
           </a:xfrm>
           <a:prstGeom prst="rect">
             <a:avLst/>
@@ -48320,7 +48424,7 @@
                 </a:solidFill>
                 <a:latin typeface="Georgia"/>
               </a:rPr>
-              <a:t>"The scheme is paying for online hours that carry no trips: Rs 314 to Rs 260 per peak online hour at a flat Rs 165 fare. Part of it may be the monsoon. Test paying per completed peak trip with an acceptance floor: city-wide, it saves Rs 58 lakh to Rs 92.7 lakh over six weeks if a half to a fifth of the idle drivers' top-up is still paid. At the evening peak the city needs about 5,000 to 5,700 drivers online, and how often people ride could move that from 2,900 to 8,600."</a:t>
+              <a:t>"The scheme is paying for online hours that carry no trips: Rs 314 to Rs 260 per peak online hour at a flat Rs 165 fare. Part of it may be the monsoon. Test paying per completed peak trip with an acceptance floor: across the enrolled drivers, it saves Rs 58 lakh to Rs 92.7 lakh over six weeks if a half to a fifth of the idle drivers' top-up is still paid, and the per-trip rate decides where it lands. At the evening peak the city needs about 5,000 to 5,700 drivers online, and how often people ride could move that from 2,900 to 8,600."</a:t>
             </a:r>
           </a:p>
         </p:txBody>
@@ -48333,7 +48437,7 @@
         </p:nvSpPr>
         <p:spPr>
           <a:xfrm>
-            <a:off x="530352" y="3660140"/>
+            <a:off x="530352" y="3718560"/>
             <a:ext cx="11130991" cy="1341120"/>
           </a:xfrm>
           <a:prstGeom prst="roundRect">
@@ -48381,7 +48485,7 @@
         </p:nvSpPr>
         <p:spPr>
           <a:xfrm>
-            <a:off x="676656" y="3788156"/>
+            <a:off x="676656" y="3846575"/>
             <a:ext cx="45720" cy="1085088"/>
           </a:xfrm>
           <a:prstGeom prst="roundRect">
@@ -48427,7 +48531,7 @@
         </p:nvSpPr>
         <p:spPr>
           <a:xfrm>
-            <a:off x="877824" y="3779012"/>
+            <a:off x="877824" y="3837431"/>
             <a:ext cx="10564063" cy="1158240"/>
           </a:xfrm>
           <a:prstGeom prst="rect">
@@ -48470,7 +48574,7 @@
         </p:nvSpPr>
         <p:spPr>
           <a:xfrm>
-            <a:off x="530352" y="5165852"/>
+            <a:off x="530352" y="5224272"/>
             <a:ext cx="11130991" cy="807720"/>
           </a:xfrm>
           <a:prstGeom prst="roundRect">
@@ -48518,7 +48622,7 @@
         </p:nvSpPr>
         <p:spPr>
           <a:xfrm>
-            <a:off x="676656" y="5293868"/>
+            <a:off x="676656" y="5352287"/>
             <a:ext cx="45720" cy="551688"/>
           </a:xfrm>
           <a:prstGeom prst="roundRect">
@@ -48564,7 +48668,7 @@
         </p:nvSpPr>
         <p:spPr>
           <a:xfrm>
-            <a:off x="877824" y="5284724"/>
+            <a:off x="877824" y="5343144"/>
             <a:ext cx="10564063" cy="624840"/>
           </a:xfrm>
           <a:prstGeom prst="rect">

</xml_diff>

<commit_message>
W04 D2: the check of the fix pass, and what it left open, closed
The per-driver-week rise sits with the 880 drivers outside the idle tail, who drove about 4 percent
more hours at an unchanged rate; the idle tail's weeks earned 12 percent less. Ramesh's slide and page
carry each added hour's Rs 350; the saving's rate can move it within the range or beyond it, by a
stated rule; the zone stop line reads six weeks against six; the checked drivers range sits inside its
wider range; the drill's table carries the bus strike and the 2023 line rule. The cold reads file
keeps the check as written, with what became of each item.

Co-Authored-By: Claude Opus 5.5 <noreply@anthropic.com>
Claude-Session: https://claude.ai/code/session_0198Piji4xg3t6od7p7Ewqmt
</commit_message>
<xml_diff>
--- a/content/W04/D2/slides/C2_W04_D02_half2_STUDENT.pptx
+++ b/content/W04/D2/slides/C2_W04_D02_half2_STUDENT.pptx
@@ -1110,7 +1110,7 @@
           </a:p>
           <a:p>
             <a:r>
-              <a:t>sentences and 6 numbers on the page, four method words against none. Notebook 07 counts them in</a:t>
+              <a:t>sentences and 7 numbers on the page, four method words against none. Notebook 07 counts them in</a:t>
             </a:r>
           </a:p>
           <a:p>
@@ -2845,12 +2845,12 @@
           <a:lstStyle/>
           <a:p>
             <a:r>
-              <a:t>LIVE, 32 minutes of silent writing; with the 3 minutes of S83 and S84 the chapter is the 35 the</a:t>
-            </a:r>
-          </a:p>
-          <a:p>
-            <a:r>
-              <a:t>brief names. Walk once early to answer scope questions and once near the</a:t>
+              <a:t>LIVE, 32 minutes of silent writing; with the 3 minutes of the chapter's opener, S83 and S84 the</a:t>
+            </a:r>
+          </a:p>
+          <a:p>
+            <a:r>
+              <a:t>chapter is the 35 the brief names. Walk once early to answer scope questions and once near the</a:t>
             </a:r>
           </a:p>
           <a:p>
@@ -3100,22 +3100,27 @@
           </a:p>
           <a:p>
             <a:r>
-              <a:t>blur the claim. The full hire-grade answer, with the per-driver-week line checked (the idle tail's</a:t>
-            </a:r>
-          </a:p>
-          <a:p>
-            <a:r>
-              <a:t>180 drivers doubled their online hours while each hour earned 17 percent less; the 140 joiners pulled</a:t>
-            </a:r>
-          </a:p>
-          <a:p>
-            <a:r>
-              <a:t>the read down), is in extras/C2_W04_D02_interview_room_STUDENT.md, and notebook 10 recomputes the</a:t>
-            </a:r>
-          </a:p>
-          <a:p>
-            <a:r>
-              <a:t>numbers it speaks.</a:t>
+              <a:t>blur the claim. The full hire-grade answer, with the per-driver-week line checked (it rose on the</a:t>
+            </a:r>
+          </a:p>
+          <a:p>
+            <a:r>
+              <a:t>880 outside the idle tail, who drove about 4 percent more hours at an unchanged Rs 313.5 an hour,</a:t>
+            </a:r>
+          </a:p>
+          <a:p>
+            <a:r>
+              <a:t>while the idle tail doubled its hours for 12 percent fewer trips and the 140 joiners pulled the read</a:t>
+            </a:r>
+          </a:p>
+          <a:p>
+            <a:r>
+              <a:t>down), is in extras/C2_W04_D02_interview_room_STUDENT.md, and notebook 10 recomputes the numbers it</a:t>
+            </a:r>
+          </a:p>
+          <a:p>
+            <a:r>
+              <a:t>speaks.</a:t>
             </a:r>
           </a:p>
           <a:p>
@@ -13836,7 +13841,7 @@
                           </a:solidFill>
                           <a:latin typeface="Calibri"/>
                         </a:rPr>
-                        <a:t>Sales per hour fell from Rs 1,190 in September to Rs 1,050 in October, and sales per customer held at Rs 100.</a:t>
+                        <a:t>Sales per hour fell from Rs 1,190 in September to Rs 1,050 in October, the two added hours selling at most Rs 350 each, and sales per customer held at Rs 100.</a:t>
                       </a:r>
                     </a:p>
                   </a:txBody>
@@ -22682,8 +22687,8 @@
         </p:blipFill>
         <p:spPr>
           <a:xfrm>
-            <a:off x="1905721" y="1664208"/>
-            <a:ext cx="8380251" cy="3256280"/>
+            <a:off x="2039073" y="1664208"/>
+            <a:ext cx="8113547" cy="3152648"/>
           </a:xfrm>
           <a:prstGeom prst="rect">
             <a:avLst/>
@@ -22698,22 +22703,22 @@
         </p:nvSpPr>
         <p:spPr>
           <a:xfrm>
-            <a:off x="530352" y="4966208"/>
-            <a:ext cx="11130991" cy="1233424"/>
-          </a:xfrm>
-          <a:prstGeom prst="rect">
-            <a:avLst/>
-          </a:prstGeom>
-          <a:noFill/>
-        </p:spPr>
-        <p:txBody>
-          <a:bodyPr wrap="square" anchor="t" lIns="0" rIns="0" tIns="0" bIns="0">
-            <a:spAutoFit/>
-          </a:bodyPr>
-          <a:lstStyle/>
-          <a:p>
-            <a:r>
-              <a:rPr sz="1600" b="1" i="0">
+            <a:off x="530352" y="4862576"/>
+            <a:ext cx="11130991" cy="1337056"/>
+          </a:xfrm>
+          <a:prstGeom prst="rect">
+            <a:avLst/>
+          </a:prstGeom>
+          <a:noFill/>
+        </p:spPr>
+        <p:txBody>
+          <a:bodyPr wrap="square" anchor="t" lIns="0" rIns="0" tIns="0" bIns="0">
+            <a:spAutoFit/>
+          </a:bodyPr>
+          <a:lstStyle/>
+          <a:p>
+            <a:r>
+              <a:rPr sz="1400" b="1" i="0">
                 <a:solidFill>
                   <a:srgbClr val="1A1440"/>
                 </a:solidFill>
@@ -22722,13 +22727,13 @@
               <a:t>Drivers online = (trips to serve an hour / trips per online driver-hour) x buffer.</a:t>
             </a:r>
             <a:r>
-              <a:rPr sz="1600" b="0" i="0">
+              <a:rPr sz="1400" b="0" i="0">
                 <a:solidFill>
                   <a:srgbClr val="1A1440"/>
                 </a:solidFill>
                 <a:latin typeface="Calibri"/>
               </a:rPr>
-              <a:t> Each leaf is a guess said aloud with its range. Counting trips per 100 people, never riders, counts a commuter who rides both ways twice. A peak trip takes about 25 minutes from accepting to dropping, so a busy driver fits 2.4 an hour; the buffer covers the busiest half hour.</a:t>
+              <a:t> Each leaf is a guess said aloud with its range. Counting trips per 100 people, never riders, counts a commuter who rides both ways twice; one in a hundred is a guess (most people take no app ride on a weekday, a rider goes out and back, and Uber is one choice among several), so it gets the widest range. A peak trip takes about 25 minutes from accepting to dropping, a guess to check first against the app's trip times, so a busy driver fits 2.4 an hour; the buffer covers the busiest half hour.</a:t>
             </a:r>
           </a:p>
         </p:txBody>
@@ -26056,7 +26061,7 @@
         <p:spPr>
           <a:xfrm>
             <a:off x="530352" y="3419856"/>
-            <a:ext cx="11130991" cy="1601216"/>
+            <a:ext cx="11130991" cy="1877568"/>
           </a:xfrm>
           <a:prstGeom prst="rect">
             <a:avLst/>
@@ -26090,7 +26095,7 @@
                 </a:solidFill>
                 <a:latin typeface="Calibri"/>
               </a:rPr>
-              <a:t> Re-run at the case's 1.90 trips an hour: 8,330 / 1.90 x 1.15 = about 5,000, so say about 5,000 to 5,700. The case pools both daily windows on all seven days (42 hours a week), so it checks the ratio's size, never the city's count, and a published count of drivers online at Hyderabad's evening peak has not been found.</a:t>
+              <a:t> Re-run at the case's 1.90 trips an hour: 8,330 / 1.90 x 1.15 = about 5,000, so say about 5,000 to 5,700 where the two routes agree, inside the 2,900 to 8,600 that trips per person sets. The case pools both daily windows on all seven days (42 hours a week), so it checks the ratio's size, never the city's count, and a published count of drivers online at Hyderabad's evening peak has not been found.</a:t>
             </a:r>
           </a:p>
         </p:txBody>
@@ -32625,7 +32630,7 @@
       </p:sp>
       <p:pic>
         <p:nvPicPr>
-          <p:cNvPr id="9" name="mermaid diagram" descr="0adedbda7aa3dede.png"/>
+          <p:cNvPr id="9" name="mermaid diagram" descr="552bed3165770c1b.png"/>
           <p:cNvPicPr>
             <a:picLocks noChangeAspect="1"/>
           </p:cNvPicPr>
@@ -32640,7 +32645,7 @@
         <p:spPr>
           <a:xfrm>
             <a:off x="2152497" y="1956816"/>
-            <a:ext cx="7886700" cy="1857375"/>
+            <a:ext cx="7886700" cy="2357437"/>
           </a:xfrm>
           <a:prstGeom prst="rect">
             <a:avLst/>
@@ -32655,7 +32660,7 @@
         </p:nvSpPr>
         <p:spPr>
           <a:xfrm>
-            <a:off x="530352" y="3960495"/>
+            <a:off x="530352" y="4460557"/>
             <a:ext cx="11130991" cy="1324864"/>
           </a:xfrm>
           <a:prstGeom prst="rect">
@@ -48424,7 +48429,7 @@
                 </a:solidFill>
                 <a:latin typeface="Georgia"/>
               </a:rPr>
-              <a:t>"The scheme is paying for online hours that carry no trips: Rs 314 to Rs 260 per peak online hour at a flat Rs 165 fare. Part of it may be the monsoon. Test paying per completed peak trip with an acceptance floor: across the enrolled drivers, it saves Rs 58 lakh to Rs 92.7 lakh over six weeks if a half to a fifth of the idle drivers' top-up is still paid, and the per-trip rate decides where it lands. At the evening peak the city needs about 5,000 to 5,700 drivers online, and how often people ride could move that from 2,900 to 8,600."</a:t>
+              <a:t>"The scheme is paying for online hours that carry no trips: Rs 314 to Rs 260 per peak online hour at a flat Rs 165 fare. Part of it may be the monsoon. Test paying per completed peak trip with an acceptance floor: across the enrolled drivers, it saves Rs 58 lakh to Rs 92.7 lakh over six weeks if a half to a fifth of the idle drivers' top-up is still paid, and the per-trip rate can move it within that range or beyond it. At the evening peak the city needs about 5,000 to 5,700 drivers online, and how often people ride could move that from 2,900 to 8,600."</a:t>
             </a:r>
           </a:p>
         </p:txBody>

</xml_diff>

<commit_message>
W04 D2: transcript 1 asks its window, fits two minutes, and stops its test on a margin
A fresh re-score held transcript 1's scope at 1 and named four rejections. The answer now asks which
weeks are compared, runs 328 words with the group breakdown moved to follow-up 1, says the idle
tail's weeks brought in less in fares, stops the test on the test half's trips per driver or a zone's
six-week wait more than half a minute above its level before the launch, and answers the monsoon with
the 880 against the 180, both at 1.90 before the launch. The scorecard, model page, studio solution,
decks, notes and notebook 10 follow, and the cold reads file keeps the re-score as written.

Co-Authored-By: Claude Opus 5.5 <noreply@anthropic.com>
Claude-Session: https://claude.ai/code/session_0198Piji4xg3t6od7p7Ewqmt
</commit_message>
<xml_diff>
--- a/content/W04/D2/slides/C2_W04_D02_half2_STUDENT.pptx
+++ b/content/W04/D2/slides/C2_W04_D02_half2_STUDENT.pptx
@@ -3100,22 +3100,22 @@
           </a:p>
           <a:p>
             <a:r>
-              <a:t>blur the claim. The full hire-grade answer, with the per-driver-week line checked (it rose on the</a:t>
-            </a:r>
-          </a:p>
-          <a:p>
-            <a:r>
-              <a:t>880 outside the idle tail, who drove about 4 percent more hours at an unchanged Rs 313.5 an hour,</a:t>
-            </a:r>
-          </a:p>
-          <a:p>
-            <a:r>
-              <a:t>while the idle tail doubled its hours for 12 percent fewer trips and the 140 joiners pulled the read</a:t>
-            </a:r>
-          </a:p>
-          <a:p>
-            <a:r>
-              <a:t>down), is in extras/C2_W04_D02_interview_room_STUDENT.md, and notebook 10 recomputes the numbers it</a:t>
+              <a:t>blur the claim. The full hire-grade answer, with the per-driver-week line checked (longer weeks,</a:t>
+            </a:r>
+          </a:p>
+          <a:p>
+            <a:r>
+              <a:t>mostly the other 880 drivers there before the launch working about 4 percent more hours at an</a:t>
+            </a:r>
+          </a:p>
+          <a:p>
+            <a:r>
+              <a:t>unchanged Rs 313.5 an hour, while the idle tail doubled its hours and brought in 12 percent less in</a:t>
+            </a:r>
+          </a:p>
+          <a:p>
+            <a:r>
+              <a:t>fares), is in extras/C2_W04_D02_interview_room_STUDENT.md, and notebook 10 recomputes the numbers it</a:t>
             </a:r>
           </a:p>
           <a:p>
@@ -40686,7 +40686,7 @@
                           </a:solidFill>
                           <a:latin typeface="Calibri"/>
                         </a:rPr>
-                        <a:t>"You are deciding whether to keep, end or change the guarantee. It is paying for online hours that carry no trips: an hour online brought in Rs 314 of fares and now brings in Rs 260 at the same fare, while the median wait barely moved, 4.8 to 4.6 minutes. Part of the fall may be the monsoon. Test paying per completed trip with an acceptance floor on half the drivers, picked at random, for six weeks, at a per-trip rate fixed first; across the enrolled drivers it saves Rs 58 lakh to Rs 92.7 lakh over six weeks if a half to a fifth of the idle top-up is still paid. You sign the test."</a:t>
+                        <a:t>"You are deciding whether to keep, end or change the guarantee. It is paying for online hours that carry no trips: an hour online brought in Rs 314 of fares and now brings in Rs 260 at the same fare, while the median wait barely moved, 4.8 to 4.6 minutes. Part of the fall may be the monsoon. Test paying per completed trip with an acceptance floor on half the drivers, picked at random, for six weeks, at a per-trip rate fixed first; rolled out to every enrolled driver it saves Rs 58 lakh to Rs 92.7 lakh over six weeks if a half to a fifth of the idle top-up is still paid. You sign the test."</a:t>
                       </a:r>
                     </a:p>
                   </a:txBody>

</xml_diff>

<commit_message>
W04 D2: every chapter closes on its map node; the twelve rows back on the sheet
S54, S85 and S90 now add chapters 5, 9 and 10 to the map as the other
closes do; S68's notes open on a hand count of the draft's method words
before the picture; the cheat sheet's panel 7 reads the twelve rows beside
all driver-weeks again. Decks and sheet rebuilt.

Co-Authored-By: Claude Opus 5.5 <noreply@anthropic.com>
Claude-Session: https://claude.ai/code/session_0198Piji4xg3t6od7p7Ewqmt
</commit_message>
<xml_diff>
--- a/content/W04/D2/slides/C2_W04_D02_half2_STUDENT.pptx
+++ b/content/W04/D2/slides/C2_W04_D02_half2_STUDENT.pptx
@@ -1105,22 +1105,27 @@
           <a:lstStyle/>
           <a:p>
             <a:r>
-              <a:t>LIVE, 1 minute. The counts come from the page itself: nine lines and 13 numbers on the draft, four</a:t>
-            </a:r>
-          </a:p>
-          <a:p>
-            <a:r>
-              <a:t>sentences and 7 numbers on the page, four method words against none. Notebook 07 counts them in</a:t>
-            </a:r>
-          </a:p>
-          <a:p>
-            <a:r>
-              <a:t>three lines and runs the five rules of S69 on both versions: the draft passes none of them.</a:t>
-            </a:r>
-          </a:p>
-          <a:p>
-            <a:r>
-              <a:t>Transition: the rules.</a:t>
+              <a:t>LIVE, 1 minute. Count one thing by hand first: how many method words does opening A on S65 carry?</a:t>
+            </a:r>
+          </a:p>
+          <a:p>
+            <a:r>
+              <a:t>Three (north star, denominator, index), and the draft's last line adds a fourth, guardrail; the</a:t>
+            </a:r>
+          </a:p>
+          <a:p>
+            <a:r>
+              <a:t>page carries none. Then the picture: nine lines and 13 numbers on the draft, four sentences and 7</a:t>
+            </a:r>
+          </a:p>
+          <a:p>
+            <a:r>
+              <a:t>numbers on the page. Notebook 07 counts them in a short loop and runs the five rules of S69 on both</a:t>
+            </a:r>
+          </a:p>
+          <a:p>
+            <a:r>
+              <a:t>versions: the draft passes none of them. Transition: the rules.</a:t>
             </a:r>
           </a:p>
         </p:txBody>
@@ -37658,9 +37663,33 @@
           </a:p>
         </p:txBody>
       </p:sp>
-      <p:sp>
-        <p:nvSpPr>
-          <p:cNvPr id="13" name="Oval 12"/>
+      <p:pic>
+        <p:nvPicPr>
+          <p:cNvPr id="13" name="mermaid diagram" descr="588a3f799e08076c.png"/>
+          <p:cNvPicPr>
+            <a:picLocks noChangeAspect="1"/>
+          </p:cNvPicPr>
+          <p:nvPr/>
+        </p:nvPicPr>
+        <p:blipFill>
+          <a:blip r:embed="rId5"/>
+          <a:stretch>
+            <a:fillRect/>
+          </a:stretch>
+        </p:blipFill>
+        <p:spPr>
+          <a:xfrm>
+            <a:off x="780897" y="3829304"/>
+            <a:ext cx="10629900" cy="1600200"/>
+          </a:xfrm>
+          <a:prstGeom prst="rect">
+            <a:avLst/>
+          </a:prstGeom>
+        </p:spPr>
+      </p:pic>
+      <p:sp>
+        <p:nvSpPr>
+          <p:cNvPr id="14" name="Oval 13"/>
           <p:cNvSpPr/>
           <p:nvPr/>
         </p:nvSpPr>
@@ -37704,7 +37733,7 @@
       </p:sp>
       <p:sp>
         <p:nvSpPr>
-          <p:cNvPr id="14" name="TextBox 13"/>
+          <p:cNvPr id="15" name="TextBox 14"/>
           <p:cNvSpPr txBox="1"/>
           <p:nvPr/>
         </p:nvSpPr>
@@ -37739,7 +37768,7 @@
       </p:sp>
       <p:sp>
         <p:nvSpPr>
-          <p:cNvPr id="15" name="Oval 14"/>
+          <p:cNvPr id="16" name="Oval 15"/>
           <p:cNvSpPr/>
           <p:nvPr/>
         </p:nvSpPr>
@@ -37783,7 +37812,7 @@
       </p:sp>
       <p:sp>
         <p:nvSpPr>
-          <p:cNvPr id="16" name="TextBox 15"/>
+          <p:cNvPr id="17" name="TextBox 16"/>
           <p:cNvSpPr txBox="1"/>
           <p:nvPr/>
         </p:nvSpPr>
@@ -37818,7 +37847,7 @@
       </p:sp>
       <p:sp>
         <p:nvSpPr>
-          <p:cNvPr id="17" name="Oval 16"/>
+          <p:cNvPr id="18" name="Oval 17"/>
           <p:cNvSpPr/>
           <p:nvPr/>
         </p:nvSpPr>
@@ -37862,7 +37891,7 @@
       </p:sp>
       <p:sp>
         <p:nvSpPr>
-          <p:cNvPr id="18" name="TextBox 17"/>
+          <p:cNvPr id="19" name="TextBox 18"/>
           <p:cNvSpPr txBox="1"/>
           <p:nvPr/>
         </p:nvSpPr>
@@ -37897,7 +37926,7 @@
       </p:sp>
       <p:sp>
         <p:nvSpPr>
-          <p:cNvPr id="19" name="Oval 18"/>
+          <p:cNvPr id="20" name="Oval 19"/>
           <p:cNvSpPr/>
           <p:nvPr/>
         </p:nvSpPr>
@@ -37941,7 +37970,7 @@
       </p:sp>
       <p:sp>
         <p:nvSpPr>
-          <p:cNvPr id="20" name="TextBox 19"/>
+          <p:cNvPr id="21" name="TextBox 20"/>
           <p:cNvSpPr txBox="1"/>
           <p:nvPr/>
         </p:nvSpPr>
@@ -37976,7 +38005,7 @@
       </p:sp>
       <p:sp>
         <p:nvSpPr>
-          <p:cNvPr id="21" name="Oval 20"/>
+          <p:cNvPr id="22" name="Oval 21"/>
           <p:cNvSpPr/>
           <p:nvPr/>
         </p:nvSpPr>
@@ -38020,7 +38049,7 @@
       </p:sp>
       <p:sp>
         <p:nvSpPr>
-          <p:cNvPr id="22" name="TextBox 21"/>
+          <p:cNvPr id="23" name="TextBox 22"/>
           <p:cNvSpPr txBox="1"/>
           <p:nvPr/>
         </p:nvSpPr>
@@ -38055,7 +38084,7 @@
       </p:sp>
       <p:sp>
         <p:nvSpPr>
-          <p:cNvPr id="23" name="TextBox 22"/>
+          <p:cNvPr id="24" name="TextBox 23"/>
           <p:cNvSpPr txBox="1"/>
           <p:nvPr/>
         </p:nvSpPr>
@@ -44610,17 +44639,41 @@
           </a:p>
         </p:txBody>
       </p:sp>
+      <p:pic>
+        <p:nvPicPr>
+          <p:cNvPr id="9" name="mermaid diagram" descr="217871f107e37084.png"/>
+          <p:cNvPicPr>
+            <a:picLocks noChangeAspect="1"/>
+          </p:cNvPicPr>
+          <p:nvPr/>
+        </p:nvPicPr>
+        <p:blipFill>
+          <a:blip r:embed="rId5"/>
+          <a:stretch>
+            <a:fillRect/>
+          </a:stretch>
+        </p:blipFill>
+        <p:spPr>
+          <a:xfrm>
+            <a:off x="530352" y="3377456"/>
+            <a:ext cx="4786326" cy="1127214"/>
+          </a:xfrm>
+          <a:prstGeom prst="rect">
+            <a:avLst/>
+          </a:prstGeom>
+        </p:spPr>
+      </p:pic>
       <p:graphicFrame>
         <p:nvGraphicFramePr>
-          <p:cNvPr id="9" name="Table 8"/>
+          <p:cNvPr id="10" name="Table 9"/>
           <p:cNvGraphicFramePr>
             <a:graphicFrameLocks noGrp="1"/>
           </p:cNvGraphicFramePr>
           <p:nvPr/>
         </p:nvGraphicFramePr>
         <p:xfrm>
-          <a:off x="530352" y="1956816"/>
-          <a:ext cx="11130989" cy="3511296"/>
+          <a:off x="5761917" y="1814068"/>
+          <a:ext cx="5899424" cy="4253992"/>
         </p:xfrm>
         <a:graphic>
           <a:graphicData uri="http://schemas.openxmlformats.org/drawingml/2006/table">
@@ -44629,19 +44682,19 @@
                 <a:tableStyleId>{2D5ABB26-0587-4C30-8999-92F81FD0307C}</a:tableStyleId>
               </a:tblPr>
               <a:tblGrid>
-                <a:gridCol w="3720477"/>
-                <a:gridCol w="1041978"/>
-                <a:gridCol w="1394413"/>
-                <a:gridCol w="4974121"/>
+                <a:gridCol w="1971198"/>
+                <a:gridCol w="914400"/>
+                <a:gridCol w="1042628"/>
+                <a:gridCol w="1971198"/>
               </a:tblGrid>
-              <a:tr h="335280">
+              <a:tr h="318008">
                 <a:tc>
                   <a:txBody>
                     <a:bodyPr/>
                     <a:lstStyle/>
                     <a:p>
                       <a:r>
-                        <a:rPr sz="1250" b="1" i="0">
+                        <a:rPr sz="1150" b="1" i="0">
                           <a:solidFill>
                             <a:srgbClr val="FFFFFF"/>
                           </a:solidFill>
@@ -44663,7 +44716,7 @@
                     <a:lstStyle/>
                     <a:p>
                       <a:r>
-                        <a:rPr sz="1250" b="1" i="0">
+                        <a:rPr sz="1150" b="1" i="0">
                           <a:solidFill>
                             <a:srgbClr val="FFFFFF"/>
                           </a:solidFill>
@@ -44685,7 +44738,7 @@
                     <a:lstStyle/>
                     <a:p>
                       <a:r>
-                        <a:rPr sz="1250" b="1" i="0">
+                        <a:rPr sz="1150" b="1" i="0">
                           <a:solidFill>
                             <a:srgbClr val="FFFFFF"/>
                           </a:solidFill>
@@ -44707,7 +44760,7 @@
                     <a:lstStyle/>
                     <a:p>
                       <a:r>
-                        <a:rPr sz="1250" b="1" i="0">
+                        <a:rPr sz="1150" b="1" i="0">
                           <a:solidFill>
                             <a:srgbClr val="FFFFFF"/>
                           </a:solidFill>
@@ -44724,14 +44777,14 @@
                   </a:tcPr>
                 </a:tc>
               </a:tr>
-              <a:tr h="542544">
+              <a:tr h="887984">
                 <a:tc>
                   <a:txBody>
                     <a:bodyPr/>
                     <a:lstStyle/>
                     <a:p>
                       <a:r>
-                        <a:rPr sz="1200" b="0" i="0">
+                        <a:rPr sz="1100" b="0" i="0">
                           <a:solidFill>
                             <a:srgbClr val="1A1440"/>
                           </a:solidFill>
@@ -44753,7 +44806,7 @@
                     <a:lstStyle/>
                     <a:p>
                       <a:r>
-                        <a:rPr sz="1200" b="0" i="0">
+                        <a:rPr sz="1100" b="0" i="0">
                           <a:solidFill>
                             <a:srgbClr val="1A1440"/>
                           </a:solidFill>
@@ -44775,7 +44828,7 @@
                     <a:lstStyle/>
                     <a:p>
                       <a:r>
-                        <a:rPr sz="1200" b="0" i="0">
+                        <a:rPr sz="1100" b="0" i="0">
                           <a:solidFill>
                             <a:srgbClr val="1A1440"/>
                           </a:solidFill>
@@ -44797,7 +44850,7 @@
                     <a:lstStyle/>
                     <a:p>
                       <a:r>
-                        <a:rPr sz="1200" b="0" i="0">
+                        <a:rPr sz="1100" b="0" i="0">
                           <a:solidFill>
                             <a:srgbClr val="1A1440"/>
                           </a:solidFill>
@@ -44814,14 +44867,14 @@
                   </a:tcPr>
                 </a:tc>
               </a:tr>
-              <a:tr h="542544">
+              <a:tr h="697992">
                 <a:tc>
                   <a:txBody>
                     <a:bodyPr/>
                     <a:lstStyle/>
                     <a:p>
                       <a:r>
-                        <a:rPr sz="1200" b="0" i="0">
+                        <a:rPr sz="1100" b="0" i="0">
                           <a:solidFill>
                             <a:srgbClr val="1A1440"/>
                           </a:solidFill>
@@ -44843,7 +44896,7 @@
                     <a:lstStyle/>
                     <a:p>
                       <a:r>
-                        <a:rPr sz="1200" b="0" i="0">
+                        <a:rPr sz="1100" b="0" i="0">
                           <a:solidFill>
                             <a:srgbClr val="1A1440"/>
                           </a:solidFill>
@@ -44865,7 +44918,7 @@
                     <a:lstStyle/>
                     <a:p>
                       <a:r>
-                        <a:rPr sz="1200" b="0" i="0">
+                        <a:rPr sz="1100" b="0" i="0">
                           <a:solidFill>
                             <a:srgbClr val="1A1440"/>
                           </a:solidFill>
@@ -44887,7 +44940,7 @@
                     <a:lstStyle/>
                     <a:p>
                       <a:r>
-                        <a:rPr sz="1200" b="0" i="0">
+                        <a:rPr sz="1100" b="0" i="0">
                           <a:solidFill>
                             <a:srgbClr val="1A1440"/>
                           </a:solidFill>
@@ -44904,14 +44957,14 @@
                   </a:tcPr>
                 </a:tc>
               </a:tr>
-              <a:tr h="335280">
+              <a:tr h="318008">
                 <a:tc>
                   <a:txBody>
                     <a:bodyPr/>
                     <a:lstStyle/>
                     <a:p>
                       <a:r>
-                        <a:rPr sz="1200" b="0" i="0">
+                        <a:rPr sz="1100" b="0" i="0">
                           <a:solidFill>
                             <a:srgbClr val="1A1440"/>
                           </a:solidFill>
@@ -44933,7 +44986,7 @@
                     <a:lstStyle/>
                     <a:p>
                       <a:r>
-                        <a:rPr sz="1200" b="0" i="0">
+                        <a:rPr sz="1100" b="0" i="0">
                           <a:solidFill>
                             <a:srgbClr val="1A1440"/>
                           </a:solidFill>
@@ -44955,7 +45008,7 @@
                     <a:lstStyle/>
                     <a:p>
                       <a:r>
-                        <a:rPr sz="1200" b="0" i="0">
+                        <a:rPr sz="1100" b="0" i="0">
                           <a:solidFill>
                             <a:srgbClr val="1A1440"/>
                           </a:solidFill>
@@ -44977,7 +45030,7 @@
                     <a:lstStyle/>
                     <a:p>
                       <a:r>
-                        <a:rPr sz="1200" b="0" i="0">
+                        <a:rPr sz="1100" b="0" i="0">
                           <a:solidFill>
                             <a:srgbClr val="1A1440"/>
                           </a:solidFill>
@@ -44994,14 +45047,14 @@
                   </a:tcPr>
                 </a:tc>
               </a:tr>
-              <a:tr h="542544">
+              <a:tr h="508000">
                 <a:tc>
                   <a:txBody>
                     <a:bodyPr/>
                     <a:lstStyle/>
                     <a:p>
                       <a:r>
-                        <a:rPr sz="1200" b="0" i="0">
+                        <a:rPr sz="1100" b="0" i="0">
                           <a:solidFill>
                             <a:srgbClr val="1A1440"/>
                           </a:solidFill>
@@ -45023,7 +45076,7 @@
                     <a:lstStyle/>
                     <a:p>
                       <a:r>
-                        <a:rPr sz="1200" b="0" i="0">
+                        <a:rPr sz="1100" b="0" i="0">
                           <a:solidFill>
                             <a:srgbClr val="1A1440"/>
                           </a:solidFill>
@@ -45045,7 +45098,7 @@
                     <a:lstStyle/>
                     <a:p>
                       <a:r>
-                        <a:rPr sz="1200" b="0" i="0">
+                        <a:rPr sz="1100" b="0" i="0">
                           <a:solidFill>
                             <a:srgbClr val="1A1440"/>
                           </a:solidFill>
@@ -45067,7 +45120,7 @@
                     <a:lstStyle/>
                     <a:p>
                       <a:r>
-                        <a:rPr sz="1200" b="0" i="0">
+                        <a:rPr sz="1100" b="0" i="0">
                           <a:solidFill>
                             <a:srgbClr val="1A1440"/>
                           </a:solidFill>
@@ -45084,14 +45137,14 @@
                   </a:tcPr>
                 </a:tc>
               </a:tr>
-              <a:tr h="335280">
+              <a:tr h="508000">
                 <a:tc>
                   <a:txBody>
                     <a:bodyPr/>
                     <a:lstStyle/>
                     <a:p>
                       <a:r>
-                        <a:rPr sz="1200" b="0" i="0">
+                        <a:rPr sz="1100" b="0" i="0">
                           <a:solidFill>
                             <a:srgbClr val="1A1440"/>
                           </a:solidFill>
@@ -45113,7 +45166,7 @@
                     <a:lstStyle/>
                     <a:p>
                       <a:r>
-                        <a:rPr sz="1200" b="0" i="0">
+                        <a:rPr sz="1100" b="0" i="0">
                           <a:solidFill>
                             <a:srgbClr val="1A1440"/>
                           </a:solidFill>
@@ -45135,7 +45188,7 @@
                     <a:lstStyle/>
                     <a:p>
                       <a:r>
-                        <a:rPr sz="1200" b="0" i="0">
+                        <a:rPr sz="1100" b="0" i="0">
                           <a:solidFill>
                             <a:srgbClr val="1A1440"/>
                           </a:solidFill>
@@ -45157,7 +45210,7 @@
                     <a:lstStyle/>
                     <a:p>
                       <a:r>
-                        <a:rPr sz="1200" b="0" i="0">
+                        <a:rPr sz="1100" b="0" i="0">
                           <a:solidFill>
                             <a:srgbClr val="1A1440"/>
                           </a:solidFill>
@@ -45174,14 +45227,14 @@
                   </a:tcPr>
                 </a:tc>
               </a:tr>
-              <a:tr h="335280">
+              <a:tr h="508000">
                 <a:tc>
                   <a:txBody>
                     <a:bodyPr/>
                     <a:lstStyle/>
                     <a:p>
                       <a:r>
-                        <a:rPr sz="1200" b="0" i="0">
+                        <a:rPr sz="1100" b="0" i="0">
                           <a:solidFill>
                             <a:srgbClr val="1A1440"/>
                           </a:solidFill>
@@ -45203,7 +45256,7 @@
                     <a:lstStyle/>
                     <a:p>
                       <a:r>
-                        <a:rPr sz="1200" b="0" i="0">
+                        <a:rPr sz="1100" b="0" i="0">
                           <a:solidFill>
                             <a:srgbClr val="1A1440"/>
                           </a:solidFill>
@@ -45225,7 +45278,7 @@
                     <a:lstStyle/>
                     <a:p>
                       <a:r>
-                        <a:rPr sz="1200" b="0" i="0">
+                        <a:rPr sz="1100" b="0" i="0">
                           <a:solidFill>
                             <a:srgbClr val="1A1440"/>
                           </a:solidFill>
@@ -45247,7 +45300,7 @@
                     <a:lstStyle/>
                     <a:p>
                       <a:r>
-                        <a:rPr sz="1200" b="0" i="0">
+                        <a:rPr sz="1100" b="0" i="0">
                           <a:solidFill>
                             <a:srgbClr val="1A1440"/>
                           </a:solidFill>
@@ -45264,14 +45317,14 @@
                   </a:tcPr>
                 </a:tc>
               </a:tr>
-              <a:tr h="542544">
+              <a:tr h="508000">
                 <a:tc>
                   <a:txBody>
                     <a:bodyPr/>
                     <a:lstStyle/>
                     <a:p>
                       <a:r>
-                        <a:rPr sz="1200" b="0" i="0">
+                        <a:rPr sz="1100" b="0" i="0">
                           <a:solidFill>
                             <a:srgbClr val="1A1440"/>
                           </a:solidFill>
@@ -45293,7 +45346,7 @@
                     <a:lstStyle/>
                     <a:p>
                       <a:r>
-                        <a:rPr sz="1200" b="0" i="0">
+                        <a:rPr sz="1100" b="0" i="0">
                           <a:solidFill>
                             <a:srgbClr val="1A1440"/>
                           </a:solidFill>
@@ -45315,7 +45368,7 @@
                     <a:lstStyle/>
                     <a:p>
                       <a:r>
-                        <a:rPr sz="1200" b="0" i="0">
+                        <a:rPr sz="1100" b="0" i="0">
                           <a:solidFill>
                             <a:srgbClr val="1A1440"/>
                           </a:solidFill>
@@ -45337,7 +45390,7 @@
                     <a:lstStyle/>
                     <a:p>
                       <a:r>
-                        <a:rPr sz="1200" b="0" i="0">
+                        <a:rPr sz="1100" b="0" i="0">
                           <a:solidFill>
                             <a:srgbClr val="1A1440"/>
                           </a:solidFill>
@@ -45360,7 +45413,7 @@
       </p:graphicFrame>
       <p:sp>
         <p:nvSpPr>
-          <p:cNvPr id="10" name="Oval 9"/>
+          <p:cNvPr id="11" name="Oval 10"/>
           <p:cNvSpPr/>
           <p:nvPr/>
         </p:nvSpPr>
@@ -45404,7 +45457,7 @@
       </p:sp>
       <p:sp>
         <p:nvSpPr>
-          <p:cNvPr id="11" name="TextBox 10"/>
+          <p:cNvPr id="12" name="TextBox 11"/>
           <p:cNvSpPr txBox="1"/>
           <p:nvPr/>
         </p:nvSpPr>
@@ -45439,7 +45492,7 @@
       </p:sp>
       <p:sp>
         <p:nvSpPr>
-          <p:cNvPr id="12" name="Oval 11"/>
+          <p:cNvPr id="13" name="Oval 12"/>
           <p:cNvSpPr/>
           <p:nvPr/>
         </p:nvSpPr>
@@ -45483,7 +45536,7 @@
       </p:sp>
       <p:sp>
         <p:nvSpPr>
-          <p:cNvPr id="13" name="TextBox 12"/>
+          <p:cNvPr id="14" name="TextBox 13"/>
           <p:cNvSpPr txBox="1"/>
           <p:nvPr/>
         </p:nvSpPr>
@@ -45518,7 +45571,7 @@
       </p:sp>
       <p:sp>
         <p:nvSpPr>
-          <p:cNvPr id="14" name="Oval 13"/>
+          <p:cNvPr id="15" name="Oval 14"/>
           <p:cNvSpPr/>
           <p:nvPr/>
         </p:nvSpPr>
@@ -45562,7 +45615,7 @@
       </p:sp>
       <p:sp>
         <p:nvSpPr>
-          <p:cNvPr id="15" name="TextBox 14"/>
+          <p:cNvPr id="16" name="TextBox 15"/>
           <p:cNvSpPr txBox="1"/>
           <p:nvPr/>
         </p:nvSpPr>
@@ -45597,7 +45650,7 @@
       </p:sp>
       <p:sp>
         <p:nvSpPr>
-          <p:cNvPr id="16" name="Oval 15"/>
+          <p:cNvPr id="17" name="Oval 16"/>
           <p:cNvSpPr/>
           <p:nvPr/>
         </p:nvSpPr>
@@ -45641,7 +45694,7 @@
       </p:sp>
       <p:sp>
         <p:nvSpPr>
-          <p:cNvPr id="17" name="TextBox 16"/>
+          <p:cNvPr id="18" name="TextBox 17"/>
           <p:cNvSpPr txBox="1"/>
           <p:nvPr/>
         </p:nvSpPr>
@@ -45676,7 +45729,7 @@
       </p:sp>
       <p:sp>
         <p:nvSpPr>
-          <p:cNvPr id="18" name="Oval 17"/>
+          <p:cNvPr id="19" name="Oval 18"/>
           <p:cNvSpPr/>
           <p:nvPr/>
         </p:nvSpPr>
@@ -45720,7 +45773,7 @@
       </p:sp>
       <p:sp>
         <p:nvSpPr>
-          <p:cNvPr id="19" name="TextBox 18"/>
+          <p:cNvPr id="20" name="TextBox 19"/>
           <p:cNvSpPr txBox="1"/>
           <p:nvPr/>
         </p:nvSpPr>
@@ -45755,7 +45808,7 @@
       </p:sp>
       <p:sp>
         <p:nvSpPr>
-          <p:cNvPr id="20" name="TextBox 19"/>
+          <p:cNvPr id="21" name="TextBox 20"/>
           <p:cNvSpPr txBox="1"/>
           <p:nvPr/>
         </p:nvSpPr>

</xml_diff>